<commit_message>
feat: replace finished/open agenda with demo/no-demo/open classification
Implement spec 002 — after fetching and classifying sprint issues, a
mandatory interactive picker (curses TUI or tkinter checkboxes) lets the
user select which resolved issues will be demoed. Template tokens change
from {{AGENDA_FINISHED}} to {{AGENDA_DEMO}} + {{AGENDA_NO_DEMO}}.
</commit_message>
<xml_diff>
--- a/tests/fixtures/template.pptx
+++ b/tests/fixtures/template.pptx
@@ -3157,8 +3157,8 @@
         </p:nvSpPr>
         <p:spPr>
           <a:xfrm>
-            <a:off x="457200" y="457200"/>
-            <a:ext cx="4114800" cy="5486400"/>
+            <a:off x="274320" y="457200"/>
+            <a:ext cx="2743200" cy="5486400"/>
           </a:xfrm>
           <a:prstGeom prst="rect">
             <a:avLst/>
@@ -3172,7 +3172,7 @@
           <a:lstStyle/>
           <a:p>
             <a:r>
-              <a:t>{{AGENDA_FINISHED}}</a:t>
+              <a:t>{{AGENDA_DEMO}}</a:t>
             </a:r>
           </a:p>
         </p:txBody>
@@ -3185,8 +3185,36 @@
         </p:nvSpPr>
         <p:spPr>
           <a:xfrm>
-            <a:off x="4572000" y="457200"/>
-            <a:ext cx="4114800" cy="5486400"/>
+            <a:off x="3200400" y="457200"/>
+            <a:ext cx="2743200" cy="5486400"/>
+          </a:xfrm>
+          <a:prstGeom prst="rect">
+            <a:avLst/>
+          </a:prstGeom>
+          <a:noFill/>
+        </p:spPr>
+        <p:txBody>
+          <a:bodyPr wrap="none">
+            <a:spAutoFit/>
+          </a:bodyPr>
+          <a:lstStyle/>
+          <a:p>
+            <a:r>
+              <a:t>{{AGENDA_NO_DEMO}}</a:t>
+            </a:r>
+          </a:p>
+        </p:txBody>
+      </p:sp>
+      <p:sp>
+        <p:nvSpPr>
+          <p:cNvPr id="4" name="TextBox 3"/>
+          <p:cNvSpPr txBox="1"/>
+          <p:nvPr/>
+        </p:nvSpPr>
+        <p:spPr>
+          <a:xfrm>
+            <a:off x="6126480" y="457200"/>
+            <a:ext cx="2743200" cy="5486400"/>
           </a:xfrm>
           <a:prstGeom prst="rect">
             <a:avLst/>

</xml_diff>

<commit_message>
feat: add optional {{SPRINT_ID}} token replaced with the sprint name
</commit_message>
<xml_diff>
--- a/tests/fixtures/template.pptx
+++ b/tests/fixtures/template.pptx
@@ -3127,6 +3127,34 @@
           <a:p>
             <a:r>
               <a:t>Recap meeting: {{RECAP_DATE}}</a:t>
+            </a:r>
+          </a:p>
+        </p:txBody>
+      </p:sp>
+      <p:sp>
+        <p:nvSpPr>
+          <p:cNvPr id="4" name="TextBox 3"/>
+          <p:cNvSpPr txBox="1"/>
+          <p:nvPr/>
+        </p:nvSpPr>
+        <p:spPr>
+          <a:xfrm>
+            <a:off x="274320" y="5943600"/>
+            <a:ext cx="3657600" cy="457200"/>
+          </a:xfrm>
+          <a:prstGeom prst="rect">
+            <a:avLst/>
+          </a:prstGeom>
+          <a:noFill/>
+        </p:spPr>
+        <p:txBody>
+          <a:bodyPr wrap="none">
+            <a:spAutoFit/>
+          </a:bodyPr>
+          <a:lstStyle/>
+          <a:p>
+            <a:r>
+              <a:t>{{SPRINT_ID}}</a:t>
             </a:r>
           </a:p>
         </p:txBody>

</xml_diff>